<commit_message>
Cap sweep: merged rib 1.0/1.4 plots on one scale, shared-scale maps; deck updated
Co-Authored-By: Claude Opus 5.5 <noreply@anthropic.com>
Claude-Session: https://claude.ai/code/session_01EHQDy7yrZwCZyHELu6KFb3
</commit_message>
<xml_diff>
--- a/results/lisbon_cap_sweep/VPI_Lisbon_Lifted_final_cap_sweep.pptx
+++ b/results/lisbon_cap_sweep/VPI_Lisbon_Lifted_final_cap_sweep.pptx
@@ -17267,998 +17267,6 @@
             </a:defRPr>
           </a:pPr>
           <a:endParaRPr lang="en-US"/>
-        </a:p>
-      </c:txPr>
-    </c:legend>
-    <c:plotVisOnly val="1"/>
-    <c:dispBlanksAs val="gap"/>
-    <c:showDLblsOverMax val="0"/>
-  </c:chart>
-  <c:txPr>
-    <a:bodyPr/>
-    <a:lstStyle/>
-    <a:p>
-      <a:pPr>
-        <a:defRPr sz="1800"/>
-      </a:pPr>
-      <a:endParaRPr lang="en-US"/>
-    </a:p>
-  </c:txPr>
-  <c:externalData r:id="rId1">
-    <c:autoUpdate val="0"/>
-  </c:externalData>
-</c:chartSpace>
-</file>
-
-<file path=ppt/charts/chart22.xml><?xml version="1.0" encoding="utf-8"?>
-<c:chartSpace xmlns:c="http://schemas.openxmlformats.org/drawingml/2006/chart" xmlns:a="http://schemas.openxmlformats.org/drawingml/2006/main" xmlns:r="http://schemas.openxmlformats.org/officeDocument/2006/relationships">
-  <c:chart>
-    <c:plotArea>
-      <c:scatterChart>
-        <c:scatterStyle val="lineMarker"/>
-        <c:varyColors val="0"/>
-        <c:ser>
-          <c:idx val="0"/>
-          <c:order val="0"/>
-          <c:tx>
-            <c:strRef>
-              <c:f>Sheet1!$B$1</c:f>
-              <c:strCache>
-                <c:ptCount val="1"/>
-                <c:pt idx="0">
-                  <c:v>rib 1.0, cap h 1.4</c:v>
-                </c:pt>
-              </c:strCache>
-            </c:strRef>
-          </c:tx>
-          <c:spPr>
-            <a:ln w="25400">
-              <a:solidFill>
-                <a:srgbClr val="2A78D6"/>
-              </a:solidFill>
-            </a:ln>
-          </c:spPr>
-          <c:marker>
-            <c:symbol val="circle"/>
-            <c:size val="6"/>
-            <c:spPr>
-              <a:solidFill>
-                <a:srgbClr val="2A78D6"/>
-              </a:solidFill>
-              <a:ln>
-                <a:solidFill>
-                  <a:srgbClr val="2A78D6"/>
-                </a:solidFill>
-              </a:ln>
-            </c:spPr>
-          </c:marker>
-          <c:xVal>
-            <c:numRef>
-              <c:f>Sheet1!$A$2:$A$11</c:f>
-              <c:numCache>
-                <c:formatCode>General</c:formatCode>
-                <c:ptCount val="10"/>
-                <c:pt idx="0">
-                  <c:v>2.0</c:v>
-                </c:pt>
-                <c:pt idx="1">
-                  <c:v>2.1</c:v>
-                </c:pt>
-                <c:pt idx="2">
-                  <c:v>2.2</c:v>
-                </c:pt>
-                <c:pt idx="3">
-                  <c:v>2.3</c:v>
-                </c:pt>
-                <c:pt idx="4">
-                  <c:v>2.4</c:v>
-                </c:pt>
-                <c:pt idx="5">
-                  <c:v>2.5</c:v>
-                </c:pt>
-                <c:pt idx="6">
-                  <c:v>2.6</c:v>
-                </c:pt>
-                <c:pt idx="7">
-                  <c:v>2.7</c:v>
-                </c:pt>
-                <c:pt idx="8">
-                  <c:v>2.8</c:v>
-                </c:pt>
-                <c:pt idx="9">
-                  <c:v>2.9</c:v>
-                </c:pt>
-              </c:numCache>
-            </c:numRef>
-          </c:xVal>
-          <c:yVal>
-            <c:numRef>
-              <c:f>Sheet1!$B$2:$B$11</c:f>
-              <c:numCache>
-                <c:formatCode>General</c:formatCode>
-                <c:ptCount val="10"/>
-                <c:pt idx="0">
-                  <c:v>2.2707</c:v>
-                </c:pt>
-                <c:pt idx="1">
-                  <c:v>2.2649</c:v>
-                </c:pt>
-                <c:pt idx="2">
-                  <c:v>2.2575</c:v>
-                </c:pt>
-                <c:pt idx="3">
-                  <c:v>2.2489</c:v>
-                </c:pt>
-                <c:pt idx="4">
-                  <c:v>2.2388</c:v>
-                </c:pt>
-                <c:pt idx="5">
-                  <c:v>2.2269</c:v>
-                </c:pt>
-                <c:pt idx="6">
-                  <c:v>2.2132</c:v>
-                </c:pt>
-                <c:pt idx="7">
-                  <c:v>2.1976</c:v>
-                </c:pt>
-                <c:pt idx="8">
-                  <c:v>2.1794</c:v>
-                </c:pt>
-                <c:pt idx="9">
-                  <c:v>2.1582</c:v>
-                </c:pt>
-              </c:numCache>
-            </c:numRef>
-          </c:yVal>
-          <c:smooth val="0"/>
-        </c:ser>
-        <c:ser>
-          <c:idx val="1"/>
-          <c:order val="1"/>
-          <c:tx>
-            <c:strRef>
-              <c:f>Sheet1!$B$13</c:f>
-              <c:strCache>
-                <c:ptCount val="1"/>
-                <c:pt idx="0">
-                  <c:v>rib 1.0, cap h 0.5</c:v>
-                </c:pt>
-              </c:strCache>
-            </c:strRef>
-          </c:tx>
-          <c:spPr>
-            <a:ln w="25400">
-              <a:solidFill>
-                <a:srgbClr val="8FB8E8"/>
-              </a:solidFill>
-              <a:prstDash val="dash"/>
-            </a:ln>
-          </c:spPr>
-          <c:marker>
-            <c:symbol val="circle"/>
-            <c:size val="6"/>
-            <c:spPr>
-              <a:solidFill>
-                <a:srgbClr val="8FB8E8"/>
-              </a:solidFill>
-              <a:ln>
-                <a:solidFill>
-                  <a:srgbClr val="8FB8E8"/>
-                </a:solidFill>
-              </a:ln>
-            </c:spPr>
-          </c:marker>
-          <c:xVal>
-            <c:numRef>
-              <c:f>Sheet1!$A$14:$A$23</c:f>
-              <c:numCache>
-                <c:formatCode>General</c:formatCode>
-                <c:ptCount val="10"/>
-                <c:pt idx="0">
-                  <c:v>2.0</c:v>
-                </c:pt>
-                <c:pt idx="1">
-                  <c:v>2.1</c:v>
-                </c:pt>
-                <c:pt idx="2">
-                  <c:v>2.2</c:v>
-                </c:pt>
-                <c:pt idx="3">
-                  <c:v>2.3</c:v>
-                </c:pt>
-                <c:pt idx="4">
-                  <c:v>2.4</c:v>
-                </c:pt>
-                <c:pt idx="5">
-                  <c:v>2.5</c:v>
-                </c:pt>
-                <c:pt idx="6">
-                  <c:v>2.6</c:v>
-                </c:pt>
-                <c:pt idx="7">
-                  <c:v>2.7</c:v>
-                </c:pt>
-                <c:pt idx="8">
-                  <c:v>2.8</c:v>
-                </c:pt>
-                <c:pt idx="9">
-                  <c:v>2.9</c:v>
-                </c:pt>
-              </c:numCache>
-            </c:numRef>
-          </c:xVal>
-          <c:yVal>
-            <c:numRef>
-              <c:f>Sheet1!$B$14:$B$23</c:f>
-              <c:numCache>
-                <c:formatCode>General</c:formatCode>
-                <c:ptCount val="10"/>
-                <c:pt idx="0">
-                  <c:v>2.215</c:v>
-                </c:pt>
-                <c:pt idx="1">
-                  <c:v>2.2097</c:v>
-                </c:pt>
-                <c:pt idx="2">
-                  <c:v>2.2036</c:v>
-                </c:pt>
-                <c:pt idx="3">
-                  <c:v>2.1969</c:v>
-                </c:pt>
-                <c:pt idx="4">
-                  <c:v>2.1896</c:v>
-                </c:pt>
-                <c:pt idx="5">
-                  <c:v>2.1813</c:v>
-                </c:pt>
-                <c:pt idx="6">
-                  <c:v>2.1722</c:v>
-                </c:pt>
-                <c:pt idx="7">
-                  <c:v>2.1621</c:v>
-                </c:pt>
-                <c:pt idx="8">
-                  <c:v>2.1506</c:v>
-                </c:pt>
-                <c:pt idx="9">
-                  <c:v>2.1373</c:v>
-                </c:pt>
-              </c:numCache>
-            </c:numRef>
-          </c:yVal>
-          <c:smooth val="0"/>
-        </c:ser>
-        <c:ser>
-          <c:idx val="2"/>
-          <c:order val="2"/>
-          <c:tx>
-            <c:strRef>
-              <c:f>Sheet1!$B$25</c:f>
-              <c:strCache>
-                <c:ptCount val="1"/>
-                <c:pt idx="0">
-                  <c:v>rib 1.4, cap h 1.4</c:v>
-                </c:pt>
-              </c:strCache>
-            </c:strRef>
-          </c:tx>
-          <c:spPr>
-            <a:ln w="25400">
-              <a:solidFill>
-                <a:srgbClr val="EB6834"/>
-              </a:solidFill>
-            </a:ln>
-          </c:spPr>
-          <c:marker>
-            <c:symbol val="circle"/>
-            <c:size val="6"/>
-            <c:spPr>
-              <a:solidFill>
-                <a:srgbClr val="EB6834"/>
-              </a:solidFill>
-              <a:ln>
-                <a:solidFill>
-                  <a:srgbClr val="EB6834"/>
-                </a:solidFill>
-              </a:ln>
-            </c:spPr>
-          </c:marker>
-          <c:xVal>
-            <c:numRef>
-              <c:f>Sheet1!$A$26:$A$35</c:f>
-              <c:numCache>
-                <c:formatCode>General</c:formatCode>
-                <c:ptCount val="10"/>
-                <c:pt idx="0">
-                  <c:v>2.0</c:v>
-                </c:pt>
-                <c:pt idx="1">
-                  <c:v>2.1</c:v>
-                </c:pt>
-                <c:pt idx="2">
-                  <c:v>2.2</c:v>
-                </c:pt>
-                <c:pt idx="3">
-                  <c:v>2.3</c:v>
-                </c:pt>
-                <c:pt idx="4">
-                  <c:v>2.4</c:v>
-                </c:pt>
-                <c:pt idx="5">
-                  <c:v>2.5</c:v>
-                </c:pt>
-                <c:pt idx="6">
-                  <c:v>2.6</c:v>
-                </c:pt>
-                <c:pt idx="7">
-                  <c:v>2.7</c:v>
-                </c:pt>
-                <c:pt idx="8">
-                  <c:v>2.8</c:v>
-                </c:pt>
-                <c:pt idx="9">
-                  <c:v>2.9</c:v>
-                </c:pt>
-              </c:numCache>
-            </c:numRef>
-          </c:xVal>
-          <c:yVal>
-            <c:numRef>
-              <c:f>Sheet1!$B$26:$B$35</c:f>
-              <c:numCache>
-                <c:formatCode>General</c:formatCode>
-                <c:ptCount val="10"/>
-                <c:pt idx="0">
-                  <c:v>2.1729</c:v>
-                </c:pt>
-                <c:pt idx="1">
-                  <c:v>2.1665</c:v>
-                </c:pt>
-                <c:pt idx="2">
-                  <c:v>2.1588</c:v>
-                </c:pt>
-                <c:pt idx="3">
-                  <c:v>2.1497</c:v>
-                </c:pt>
-                <c:pt idx="4">
-                  <c:v>2.1393</c:v>
-                </c:pt>
-                <c:pt idx="5">
-                  <c:v>2.1273</c:v>
-                </c:pt>
-                <c:pt idx="6">
-                  <c:v>2.1135</c:v>
-                </c:pt>
-                <c:pt idx="7">
-                  <c:v>2.0977</c:v>
-                </c:pt>
-                <c:pt idx="8">
-                  <c:v>2.0796</c:v>
-                </c:pt>
-                <c:pt idx="9">
-                  <c:v>2.0586</c:v>
-                </c:pt>
-              </c:numCache>
-            </c:numRef>
-          </c:yVal>
-          <c:smooth val="0"/>
-        </c:ser>
-        <c:ser>
-          <c:idx val="3"/>
-          <c:order val="3"/>
-          <c:tx>
-            <c:strRef>
-              <c:f>Sheet1!$B$37</c:f>
-              <c:strCache>
-                <c:ptCount val="1"/>
-                <c:pt idx="0">
-                  <c:v>rib 1.4, cap h 0.5</c:v>
-                </c:pt>
-              </c:strCache>
-            </c:strRef>
-          </c:tx>
-          <c:spPr>
-            <a:ln w="25400">
-              <a:solidFill>
-                <a:srgbClr val="F5B08A"/>
-              </a:solidFill>
-              <a:prstDash val="dash"/>
-            </a:ln>
-          </c:spPr>
-          <c:marker>
-            <c:symbol val="circle"/>
-            <c:size val="6"/>
-            <c:spPr>
-              <a:solidFill>
-                <a:srgbClr val="F5B08A"/>
-              </a:solidFill>
-              <a:ln>
-                <a:solidFill>
-                  <a:srgbClr val="F5B08A"/>
-                </a:solidFill>
-              </a:ln>
-            </c:spPr>
-          </c:marker>
-          <c:xVal>
-            <c:numRef>
-              <c:f>Sheet1!$A$38:$A$47</c:f>
-              <c:numCache>
-                <c:formatCode>General</c:formatCode>
-                <c:ptCount val="10"/>
-                <c:pt idx="0">
-                  <c:v>2.0</c:v>
-                </c:pt>
-                <c:pt idx="1">
-                  <c:v>2.1</c:v>
-                </c:pt>
-                <c:pt idx="2">
-                  <c:v>2.2</c:v>
-                </c:pt>
-                <c:pt idx="3">
-                  <c:v>2.3</c:v>
-                </c:pt>
-                <c:pt idx="4">
-                  <c:v>2.4</c:v>
-                </c:pt>
-                <c:pt idx="5">
-                  <c:v>2.5</c:v>
-                </c:pt>
-                <c:pt idx="6">
-                  <c:v>2.6</c:v>
-                </c:pt>
-                <c:pt idx="7">
-                  <c:v>2.7</c:v>
-                </c:pt>
-                <c:pt idx="8">
-                  <c:v>2.8</c:v>
-                </c:pt>
-                <c:pt idx="9">
-                  <c:v>2.9</c:v>
-                </c:pt>
-              </c:numCache>
-            </c:numRef>
-          </c:xVal>
-          <c:yVal>
-            <c:numRef>
-              <c:f>Sheet1!$B$38:$B$47</c:f>
-              <c:numCache>
-                <c:formatCode>General</c:formatCode>
-                <c:ptCount val="10"/>
-                <c:pt idx="0">
-                  <c:v>2.121</c:v>
-                </c:pt>
-                <c:pt idx="1">
-                  <c:v>2.1153</c:v>
-                </c:pt>
-                <c:pt idx="2">
-                  <c:v>2.109</c:v>
-                </c:pt>
-                <c:pt idx="3">
-                  <c:v>2.1021</c:v>
-                </c:pt>
-                <c:pt idx="4">
-                  <c:v>2.0945</c:v>
-                </c:pt>
-                <c:pt idx="5">
-                  <c:v>2.0861</c:v>
-                </c:pt>
-                <c:pt idx="6">
-                  <c:v>2.0769</c:v>
-                </c:pt>
-                <c:pt idx="7">
-                  <c:v>2.0666</c:v>
-                </c:pt>
-                <c:pt idx="8">
-                  <c:v>2.055</c:v>
-                </c:pt>
-                <c:pt idx="9">
-                  <c:v>2.0417</c:v>
-                </c:pt>
-              </c:numCache>
-            </c:numRef>
-          </c:yVal>
-          <c:smooth val="0"/>
-        </c:ser>
-        <c:axId val="-2128940872"/>
-        <c:axId val="-2129643912"/>
-      </c:scatterChart>
-      <c:valAx>
-        <c:axId val="-2128940872"/>
-        <c:scaling>
-          <c:orientation val="minMax"/>
-          <c:max val="2.9"/>
-          <c:min val="2.0"/>
-        </c:scaling>
-        <c:delete val="0"/>
-        <c:axPos val="b"/>
-        <c:title>
-          <c:tx>
-            <c:rich>
-              <a:bodyPr/>
-              <a:lstStyle/>
-              <a:p>
-                <a:r>
-                  <a:rPr sz="1100" b="0">
-                    <a:latin typeface="Arial"/>
-                  </a:rPr>
-                  <a:t>Cap width (µm)</a:t>
-                </a:r>
-              </a:p>
-            </c:rich>
-          </c:tx>
-          <c:layout/>
-          <c:overlay val="0"/>
-        </c:title>
-        <c:numFmt formatCode="General" sourceLinked="1"/>
-        <c:majorTickMark val="out"/>
-        <c:minorTickMark val="none"/>
-        <c:tickLblPos val="nextTo"/>
-        <c:txPr>
-          <a:bodyPr/>
-          <a:lstStyle/>
-          <a:p>
-            <a:pPr>
-              <a:defRPr sz="1000">
-                <a:latin typeface="Arial"/>
-              </a:defRPr>
-            </a:pPr>
-          </a:p>
-        </c:txPr>
-        <c:crossAx val="-2129643912"/>
-        <c:crosses val="autoZero"/>
-        <c:crossBetween val="midCat"/>
-        <c:majorUnit val="0.1"/>
-      </c:valAx>
-      <c:valAx>
-        <c:axId val="-2129643912"/>
-        <c:scaling>
-          <c:orientation val="minMax"/>
-          <c:max val="2.3"/>
-          <c:min val="2.0"/>
-        </c:scaling>
-        <c:delete val="0"/>
-        <c:axPos val="l"/>
-        <c:majorGridlines>
-          <c:spPr>
-            <a:ln>
-              <a:solidFill>
-                <a:srgbClr val="E3E3E3"/>
-              </a:solidFill>
-            </a:ln>
-          </c:spPr>
-        </c:majorGridlines>
-        <c:title>
-          <c:tx>
-            <c:rich>
-              <a:bodyPr/>
-              <a:lstStyle/>
-              <a:p>
-                <a:r>
-                  <a:rPr sz="1100" b="0">
-                    <a:latin typeface="Arial"/>
-                  </a:rPr>
-                  <a:t>Vπ·L (V·cm)</a:t>
-                </a:r>
-              </a:p>
-            </c:rich>
-          </c:tx>
-          <c:layout/>
-          <c:overlay val="0"/>
-        </c:title>
-        <c:numFmt formatCode="General" sourceLinked="0"/>
-        <c:majorTickMark val="out"/>
-        <c:minorTickMark val="none"/>
-        <c:tickLblPos val="nextTo"/>
-        <c:txPr>
-          <a:bodyPr/>
-          <a:lstStyle/>
-          <a:p>
-            <a:pPr>
-              <a:defRPr sz="1000">
-                <a:latin typeface="Arial"/>
-              </a:defRPr>
-            </a:pPr>
-          </a:p>
-        </c:txPr>
-        <c:crossAx val="-2128940872"/>
-        <c:crosses val="autoZero"/>
-        <c:crossBetween val="midCat"/>
-        <c:majorUnit val="0.05"/>
-      </c:valAx>
-    </c:plotArea>
-    <c:legend>
-      <c:legendPos val="t"/>
-      <c:layout/>
-      <c:overlay val="0"/>
-      <c:txPr>
-        <a:bodyPr/>
-        <a:lstStyle/>
-        <a:p>
-          <a:pPr>
-            <a:defRPr sz="900">
-              <a:latin typeface="Arial"/>
-            </a:defRPr>
-          </a:pPr>
-        </a:p>
-      </c:txPr>
-    </c:legend>
-    <c:plotVisOnly val="1"/>
-    <c:dispBlanksAs val="gap"/>
-    <c:showDLblsOverMax val="0"/>
-  </c:chart>
-  <c:txPr>
-    <a:bodyPr/>
-    <a:lstStyle/>
-    <a:p>
-      <a:pPr>
-        <a:defRPr sz="1800"/>
-      </a:pPr>
-      <a:endParaRPr lang="en-US"/>
-    </a:p>
-  </c:txPr>
-  <c:externalData r:id="rId1">
-    <c:autoUpdate val="0"/>
-  </c:externalData>
-</c:chartSpace>
-</file>
-
-<file path=ppt/charts/chart23.xml><?xml version="1.0" encoding="utf-8"?>
-<c:chartSpace xmlns:c="http://schemas.openxmlformats.org/drawingml/2006/chart" xmlns:a="http://schemas.openxmlformats.org/drawingml/2006/main" xmlns:r="http://schemas.openxmlformats.org/officeDocument/2006/relationships">
-  <c:chart>
-    <c:plotArea>
-      <c:scatterChart>
-        <c:scatterStyle val="lineMarker"/>
-        <c:varyColors val="0"/>
-        <c:ser>
-          <c:idx val="0"/>
-          <c:order val="0"/>
-          <c:tx>
-            <c:strRef>
-              <c:f>Sheet1!$B$1</c:f>
-              <c:strCache>
-                <c:ptCount val="1"/>
-                <c:pt idx="0">
-                  <c:v>rib 1.0, cap h 1.4</c:v>
-                </c:pt>
-              </c:strCache>
-            </c:strRef>
-          </c:tx>
-          <c:spPr>
-            <a:ln w="25400">
-              <a:solidFill>
-                <a:srgbClr val="2A78D6"/>
-              </a:solidFill>
-            </a:ln>
-          </c:spPr>
-          <c:marker>
-            <c:symbol val="circle"/>
-            <c:size val="6"/>
-            <c:spPr>
-              <a:solidFill>
-                <a:srgbClr val="2A78D6"/>
-              </a:solidFill>
-              <a:ln>
-                <a:solidFill>
-                  <a:srgbClr val="2A78D6"/>
-                </a:solidFill>
-              </a:ln>
-            </c:spPr>
-          </c:marker>
-          <c:xVal>
-            <c:numRef>
-              <c:f>Sheet1!$A$2:$A$11</c:f>
-              <c:numCache>
-                <c:formatCode>General</c:formatCode>
-                <c:ptCount val="10"/>
-                <c:pt idx="0">
-                  <c:v>2.0</c:v>
-                </c:pt>
-                <c:pt idx="1">
-                  <c:v>2.1</c:v>
-                </c:pt>
-                <c:pt idx="2">
-                  <c:v>2.2</c:v>
-                </c:pt>
-                <c:pt idx="3">
-                  <c:v>2.3</c:v>
-                </c:pt>
-                <c:pt idx="4">
-                  <c:v>2.4</c:v>
-                </c:pt>
-                <c:pt idx="5">
-                  <c:v>2.5</c:v>
-                </c:pt>
-                <c:pt idx="6">
-                  <c:v>2.6</c:v>
-                </c:pt>
-                <c:pt idx="7">
-                  <c:v>2.7</c:v>
-                </c:pt>
-                <c:pt idx="8">
-                  <c:v>2.8</c:v>
-                </c:pt>
-                <c:pt idx="9">
-                  <c:v>2.9</c:v>
-                </c:pt>
-              </c:numCache>
-            </c:numRef>
-          </c:xVal>
-          <c:yVal>
-            <c:numRef>
-              <c:f>Sheet1!$B$2:$B$11</c:f>
-              <c:numCache>
-                <c:formatCode>General</c:formatCode>
-                <c:ptCount val="10"/>
-                <c:pt idx="0">
-                  <c:v>0.02603</c:v>
-                </c:pt>
-                <c:pt idx="1">
-                  <c:v>0.0264</c:v>
-                </c:pt>
-                <c:pt idx="2">
-                  <c:v>0.02679</c:v>
-                </c:pt>
-                <c:pt idx="3">
-                  <c:v>0.02725</c:v>
-                </c:pt>
-                <c:pt idx="4">
-                  <c:v>0.02773</c:v>
-                </c:pt>
-                <c:pt idx="5">
-                  <c:v>0.02827</c:v>
-                </c:pt>
-                <c:pt idx="6">
-                  <c:v>0.02891</c:v>
-                </c:pt>
-                <c:pt idx="7">
-                  <c:v>0.02962</c:v>
-                </c:pt>
-                <c:pt idx="8">
-                  <c:v>0.0305</c:v>
-                </c:pt>
-                <c:pt idx="9">
-                  <c:v>0.03156</c:v>
-                </c:pt>
-              </c:numCache>
-            </c:numRef>
-          </c:yVal>
-          <c:smooth val="0"/>
-        </c:ser>
-        <c:ser>
-          <c:idx val="1"/>
-          <c:order val="1"/>
-          <c:tx>
-            <c:strRef>
-              <c:f>Sheet1!$B$13</c:f>
-              <c:strCache>
-                <c:ptCount val="1"/>
-                <c:pt idx="0">
-                  <c:v>rib 1.4, cap h 1.4</c:v>
-                </c:pt>
-              </c:strCache>
-            </c:strRef>
-          </c:tx>
-          <c:spPr>
-            <a:ln w="25400">
-              <a:solidFill>
-                <a:srgbClr val="EB6834"/>
-              </a:solidFill>
-            </a:ln>
-          </c:spPr>
-          <c:marker>
-            <c:symbol val="circle"/>
-            <c:size val="6"/>
-            <c:spPr>
-              <a:solidFill>
-                <a:srgbClr val="EB6834"/>
-              </a:solidFill>
-              <a:ln>
-                <a:solidFill>
-                  <a:srgbClr val="EB6834"/>
-                </a:solidFill>
-              </a:ln>
-            </c:spPr>
-          </c:marker>
-          <c:xVal>
-            <c:numRef>
-              <c:f>Sheet1!$A$14:$A$23</c:f>
-              <c:numCache>
-                <c:formatCode>General</c:formatCode>
-                <c:ptCount val="10"/>
-                <c:pt idx="0">
-                  <c:v>2.0</c:v>
-                </c:pt>
-                <c:pt idx="1">
-                  <c:v>2.1</c:v>
-                </c:pt>
-                <c:pt idx="2">
-                  <c:v>2.2</c:v>
-                </c:pt>
-                <c:pt idx="3">
-                  <c:v>2.3</c:v>
-                </c:pt>
-                <c:pt idx="4">
-                  <c:v>2.4</c:v>
-                </c:pt>
-                <c:pt idx="5">
-                  <c:v>2.5</c:v>
-                </c:pt>
-                <c:pt idx="6">
-                  <c:v>2.6</c:v>
-                </c:pt>
-                <c:pt idx="7">
-                  <c:v>2.7</c:v>
-                </c:pt>
-                <c:pt idx="8">
-                  <c:v>2.8</c:v>
-                </c:pt>
-                <c:pt idx="9">
-                  <c:v>2.9</c:v>
-                </c:pt>
-              </c:numCache>
-            </c:numRef>
-          </c:xVal>
-          <c:yVal>
-            <c:numRef>
-              <c:f>Sheet1!$B$14:$B$23</c:f>
-              <c:numCache>
-                <c:formatCode>General</c:formatCode>
-                <c:ptCount val="10"/>
-                <c:pt idx="0">
-                  <c:v>0.02789</c:v>
-                </c:pt>
-                <c:pt idx="1">
-                  <c:v>0.02835</c:v>
-                </c:pt>
-                <c:pt idx="2">
-                  <c:v>0.02884</c:v>
-                </c:pt>
-                <c:pt idx="3">
-                  <c:v>0.02937</c:v>
-                </c:pt>
-                <c:pt idx="4">
-                  <c:v>0.02996</c:v>
-                </c:pt>
-                <c:pt idx="5">
-                  <c:v>0.0306</c:v>
-                </c:pt>
-                <c:pt idx="6">
-                  <c:v>0.03133</c:v>
-                </c:pt>
-                <c:pt idx="7">
-                  <c:v>0.03217</c:v>
-                </c:pt>
-                <c:pt idx="8">
-                  <c:v>0.03316</c:v>
-                </c:pt>
-                <c:pt idx="9">
-                  <c:v>0.03436</c:v>
-                </c:pt>
-              </c:numCache>
-            </c:numRef>
-          </c:yVal>
-          <c:smooth val="0"/>
-        </c:ser>
-        <c:axId val="-2128940872"/>
-        <c:axId val="-2129643912"/>
-      </c:scatterChart>
-      <c:valAx>
-        <c:axId val="-2128940872"/>
-        <c:scaling>
-          <c:orientation val="minMax"/>
-          <c:max val="2.9"/>
-          <c:min val="2.0"/>
-        </c:scaling>
-        <c:delete val="0"/>
-        <c:axPos val="b"/>
-        <c:title>
-          <c:tx>
-            <c:rich>
-              <a:bodyPr/>
-              <a:lstStyle/>
-              <a:p>
-                <a:r>
-                  <a:rPr sz="1100" b="0">
-                    <a:latin typeface="Arial"/>
-                  </a:rPr>
-                  <a:t>Cap width (µm)</a:t>
-                </a:r>
-              </a:p>
-            </c:rich>
-          </c:tx>
-          <c:layout/>
-          <c:overlay val="0"/>
-        </c:title>
-        <c:numFmt formatCode="General" sourceLinked="1"/>
-        <c:majorTickMark val="out"/>
-        <c:minorTickMark val="none"/>
-        <c:tickLblPos val="nextTo"/>
-        <c:txPr>
-          <a:bodyPr/>
-          <a:lstStyle/>
-          <a:p>
-            <a:pPr>
-              <a:defRPr sz="1000">
-                <a:latin typeface="Arial"/>
-              </a:defRPr>
-            </a:pPr>
-          </a:p>
-        </c:txPr>
-        <c:crossAx val="-2129643912"/>
-        <c:crosses val="autoZero"/>
-        <c:crossBetween val="midCat"/>
-        <c:majorUnit val="0.1"/>
-      </c:valAx>
-      <c:valAx>
-        <c:axId val="-2129643912"/>
-        <c:scaling>
-          <c:orientation val="minMax"/>
-          <c:max val="0.035"/>
-          <c:min val="0.025"/>
-        </c:scaling>
-        <c:delete val="0"/>
-        <c:axPos val="l"/>
-        <c:majorGridlines>
-          <c:spPr>
-            <a:ln>
-              <a:solidFill>
-                <a:srgbClr val="E3E3E3"/>
-              </a:solidFill>
-            </a:ln>
-          </c:spPr>
-        </c:majorGridlines>
-        <c:title>
-          <c:tx>
-            <c:rich>
-              <a:bodyPr/>
-              <a:lstStyle/>
-              <a:p>
-                <a:r>
-                  <a:rPr sz="1100" b="0">
-                    <a:latin typeface="Arial"/>
-                  </a:rPr>
-                  <a:t>Insertion loss (dB/cm)</a:t>
-                </a:r>
-              </a:p>
-            </c:rich>
-          </c:tx>
-          <c:layout/>
-          <c:overlay val="0"/>
-        </c:title>
-        <c:numFmt formatCode="General" sourceLinked="0"/>
-        <c:majorTickMark val="out"/>
-        <c:minorTickMark val="none"/>
-        <c:tickLblPos val="nextTo"/>
-        <c:txPr>
-          <a:bodyPr/>
-          <a:lstStyle/>
-          <a:p>
-            <a:pPr>
-              <a:defRPr sz="1000">
-                <a:latin typeface="Arial"/>
-              </a:defRPr>
-            </a:pPr>
-          </a:p>
-        </c:txPr>
-        <c:crossAx val="-2128940872"/>
-        <c:crosses val="autoZero"/>
-        <c:crossBetween val="midCat"/>
-        <c:majorUnit val="0.002"/>
-      </c:valAx>
-    </c:plotArea>
-    <c:legend>
-      <c:legendPos val="t"/>
-      <c:layout/>
-      <c:overlay val="0"/>
-      <c:txPr>
-        <a:bodyPr/>
-        <a:lstStyle/>
-        <a:p>
-          <a:pPr>
-            <a:defRPr sz="900">
-              <a:latin typeface="Arial"/>
-            </a:defRPr>
-          </a:pPr>
         </a:p>
       </c:txPr>
     </c:legend>
@@ -38479,14 +37487,14 @@
                 </a:solidFill>
                 <a:latin typeface="Arial"/>
               </a:rPr>
-              <a:t>Each cell is one simulation; rib 1.0 µm (top) and 1.4 µm (bottom)</a:t>
+              <a:t>One colour scale per quantity: rib 1.0 µm (top) and 1.4 µm (bottom) directly comparable</a:t>
             </a:r>
           </a:p>
         </p:txBody>
       </p:sp>
       <p:pic>
         <p:nvPicPr>
-          <p:cNvPr id="4" name="Picture 3" descr="cap_sweep_maps.png"/>
+          <p:cNvPr id="4" name="Picture 3" descr="cap_sweep_maps_shared_scale.png"/>
           <p:cNvPicPr>
             <a:picLocks noChangeAspect="1"/>
           </p:cNvPicPr>
@@ -38599,50 +37607,38 @@
                 </a:solidFill>
                 <a:latin typeface="Arial"/>
               </a:rPr>
-              <a:t>Cuts at the tallest (1.4 µm) and lowest (0.5 µm) cap</a:t>
+              <a:t>Both rib widths on one scale; colour = cap height, solid = rib 1.0 µm, dashed = rib 1.4 µm</a:t>
             </a:r>
           </a:p>
         </p:txBody>
       </p:sp>
-      <p:graphicFrame>
-        <p:nvGraphicFramePr>
-          <p:cNvPr id="4" name="Chart 3"/>
-          <p:cNvGraphicFramePr>
-            <a:graphicFrameLocks noGrp="1"/>
-          </p:cNvGraphicFramePr>
+      <p:pic>
+        <p:nvPicPr>
+          <p:cNvPr id="4" name="Picture 3" descr="cap_sweep_merged_lines.png"/>
+          <p:cNvPicPr>
+            <a:picLocks noChangeAspect="1"/>
+          </p:cNvPicPr>
           <p:nvPr/>
-        </p:nvGraphicFramePr>
-        <p:xfrm>
-          <a:off x="548640" y="1600200"/>
-          <a:ext cx="5486400" cy="3657600"/>
-        </p:xfrm>
-        <a:graphic>
-          <a:graphicData uri="http://schemas.openxmlformats.org/drawingml/2006/chart">
-            <c:chart xmlns:c="http://schemas.openxmlformats.org/drawingml/2006/chart" r:id="rId2"/>
-          </a:graphicData>
-        </a:graphic>
-      </p:graphicFrame>
-      <p:graphicFrame>
-        <p:nvGraphicFramePr>
-          <p:cNvPr id="5" name="Chart 4"/>
-          <p:cNvGraphicFramePr>
-            <a:graphicFrameLocks noGrp="1"/>
-          </p:cNvGraphicFramePr>
-          <p:nvPr/>
-        </p:nvGraphicFramePr>
-        <p:xfrm>
-          <a:off x="6217920" y="1600200"/>
-          <a:ext cx="5486400" cy="3657600"/>
-        </p:xfrm>
-        <a:graphic>
-          <a:graphicData uri="http://schemas.openxmlformats.org/drawingml/2006/chart">
-            <c:chart xmlns:c="http://schemas.openxmlformats.org/drawingml/2006/chart" r:id="rId3"/>
-          </a:graphicData>
-        </a:graphic>
-      </p:graphicFrame>
+        </p:nvPicPr>
+        <p:blipFill>
+          <a:blip r:embed="rId2"/>
+          <a:stretch>
+            <a:fillRect/>
+          </a:stretch>
+        </p:blipFill>
+        <p:spPr>
+          <a:xfrm>
+            <a:off x="822960" y="1508760"/>
+            <a:ext cx="10075333" cy="3886200"/>
+          </a:xfrm>
+          <a:prstGeom prst="rect">
+            <a:avLst/>
+          </a:prstGeom>
+        </p:spPr>
+      </p:pic>
       <p:sp>
         <p:nvSpPr>
-          <p:cNvPr id="6" name="TextBox 5"/>
+          <p:cNvPr id="5" name="TextBox 4"/>
           <p:cNvSpPr txBox="1"/>
           <p:nvPr/>
         </p:nvSpPr>
@@ -38674,7 +37670,7 @@
                 </a:solidFill>
                 <a:latin typeface="Arial"/>
               </a:rPr>
-              <a:t>≈ 1 % of Vπ·L costs ≈ 4 % of IL; even the widest cap stays below 0.035 dB/cm, &gt; 10× below unbuffered Cordoba. A lower cap gives up to 2.5 % extra Vπ·L for free.</a:t>
+              <a:t>≈ 1 % of Vπ·L costs ≈ 4 % of IL; even the widest cap stays below 0.035 dB/cm, &gt; 10× below unbuffered Cordoba. The 1.4 µm rib: ≈ 0.1 V·cm lower Vπ·L, ≈ 7–9 % higher IL, independent of the cap.</a:t>
             </a:r>
           </a:p>
         </p:txBody>

</xml_diff>